<commit_message>
sync(azure-update-customer-pptx): update range and ordering
</commit_message>
<xml_diff>
--- a/azure-update-customer-pptx/assets/template/azure-update-template.pptx
+++ b/azure-update-customer-pptx/assets/template/azure-update-template.pptx
@@ -7614,7 +7614,9 @@
           <a:bodyPr/>
           <a:lstStyle/>
           <a:p>
-            <a:endParaRPr kumimoji="1" lang="ja-JP" altLang="en-US"/>
+            <a:r>
+              <a:t>{{PUBLICATION_PERIOD}}</a:t>
+            </a:r>
           </a:p>
         </p:txBody>
       </p:sp>
@@ -7803,7 +7805,9 @@
           <a:bodyPr/>
           <a:lstStyle/>
           <a:p>
-            <a:endParaRPr kumimoji="1" lang="ja-JP" altLang="en-US"/>
+            <a:r>
+              <a:t>{{PUBLICATION_PERIOD}}</a:t>
+            </a:r>
           </a:p>
         </p:txBody>
       </p:sp>
@@ -7992,7 +7996,9 @@
           <a:bodyPr/>
           <a:lstStyle/>
           <a:p>
-            <a:endParaRPr kumimoji="1" lang="ja-JP" altLang="en-US"/>
+            <a:r>
+              <a:t>{{PUBLICATION_PERIOD}}</a:t>
+            </a:r>
           </a:p>
         </p:txBody>
       </p:sp>

</xml_diff>